<commit_message>
Addition to PP about repo differences
</commit_message>
<xml_diff>
--- a/presentation/azure-devops-to-github-the-great-migration-FULL-DECK.pptx
+++ b/presentation/azure-devops-to-github-the-great-migration-FULL-DECK.pptx
@@ -6816,6 +6816,90 @@
               <a:t>Identities carried over as mannequins</a:t>
             </a:r>
             <a:endParaRPr lang="en-US" sz="1600" dirty="0"/>
+          </a:p>
+        </p:txBody>
+      </p:sp>
+      <p:sp>
+        <p:nvSpPr>
+          <p:cNvPr id="13" name="Shape 13"/>
+          <p:cNvSpPr/>
+          <p:nvPr/>
+        </p:nvSpPr>
+        <p:spPr>
+          <a:xfrm>
+            <a:off x="548640" y="5852160"/>
+            <a:ext cx="11064240" cy="868680"/>
+          </a:xfrm>
+          <a:prstGeom prst="roundRect">
+            <a:avLst>
+              <a:gd name="adj" fmla="val 12632"/>
+            </a:avLst>
+          </a:prstGeom>
+          <a:solidFill>
+            <a:srgbClr val="1F3D2C"/>
+          </a:solidFill>
+          <a:ln w="12700">
+            <a:noFill/>
+            <a:prstDash val="solid"/>
+          </a:ln>
+          <a:effectLst>
+            <a:outerShdw blurRad="76200" dist="25400" dir="5400000" algn="bl" rotWithShape="0">
+              <a:srgbClr val="000000">
+                <a:alpha val="12000"/>
+              </a:srgbClr>
+            </a:outerShdw>
+          </a:effectLst>
+        </p:spPr>
+        <p:txBody>
+          <a:bodyPr/>
+          <a:lstStyle/>
+          <a:p>
+            <a:endParaRPr lang="en-US"/>
+          </a:p>
+        </p:txBody>
+      </p:sp>
+      <p:sp>
+        <p:nvSpPr>
+          <p:cNvPr id="14" name="Text 14"/>
+          <p:cNvSpPr txBox="1"/>
+          <p:nvPr/>
+        </p:nvSpPr>
+        <p:spPr>
+          <a:xfrm>
+            <a:off x="548640" y="5852160"/>
+            <a:ext cx="11064240" cy="868680"/>
+          </a:xfrm>
+          <a:prstGeom prst="rect">
+            <a:avLst/>
+          </a:prstGeom>
+          <a:noFill/>
+          <a:ln/>
+        </p:spPr>
+        <p:txBody>
+          <a:bodyPr wrap="square" lIns="256032" tIns="54864" rIns="256032" bIns="54864" rtlCol="0" anchor="ctr"/>
+          <a:lstStyle/>
+          <a:p>
+            <a:pPr marL="0" indent="0" algn="l">
+              <a:buNone/>
+            </a:pPr>
+            <a:r>
+              <a:rPr sz="1250" b="1" spc="120">
+                <a:solidFill>
+                  <a:srgbClr val="E0B85C"/>
+                </a:solidFill>
+                <a:latin typeface="Calibri"/>
+              </a:rPr>
+              <a:t>TAKEAWAY </a:t>
+            </a:r>
+            <a:r>
+              <a:rPr sz="1500" b="0">
+                <a:solidFill>
+                  <a:srgbClr val="F5F5F0"/>
+                </a:solidFill>
+                <a:latin typeface="Calibri"/>
+              </a:rPr>
+              <a:t>The word “repo” survives the migration. The project-level boundary it used to sit inside — shared config, ownership, access — doesn’t come with it.</a:t>
+            </a:r>
           </a:p>
         </p:txBody>
       </p:sp>
@@ -13091,22 +13175,35 @@
               <a:buChar char="•"/>
             </a:pPr>
             <a:r>
-              <a:rPr lang="en-US" sz="1450" dirty="0"/>
-              <a:t>GitHub Enterprise Importer (GEI) is a set of GitHub CLI extensions, with </a:t>
-            </a:r>
-            <a:r>
               <a:rPr lang="en-US" sz="1450" dirty="0">
+                <a:solidFill>
+                  <a:srgbClr val="2B2B2B"/>
+                </a:solidFill>
+              </a:rPr>
+              <a:t>GitHub Enterprise Importer (GEI) is a set of GitHub CLI extensions (including </a:t>
+            </a:r>
+            <a:r>
+              <a:rPr lang="en-US" sz="1450" dirty="0">
+                <a:solidFill>
+                  <a:srgbClr val="2B2B2B"/>
+                </a:solidFill>
                 <a:latin typeface="Cascadia Code" panose="020B0609020000020004" pitchFamily="49" charset="0"/>
                 <a:cs typeface="Cascadia Code" panose="020B0609020000020004" pitchFamily="49" charset="0"/>
               </a:rPr>
-              <a:t>gh-ado2gh</a:t>
-            </a:r>
-            <a:r>
-              <a:rPr lang="en-US" sz="1450" dirty="0"/>
-              <a:t> specifically for ADO</a:t>
+              <a:t>ado2gh</a:t>
+            </a:r>
+            <a:r>
+              <a:rPr lang="en-US" sz="1450" dirty="0">
+                <a:solidFill>
+                  <a:srgbClr val="2B2B2B"/>
+                </a:solidFill>
+              </a:rPr>
+              <a:t>)</a:t>
             </a:r>
             <a:endParaRPr lang="en-US" sz="1450" dirty="0">
-              <a:latin typeface="Cascadia Mono" panose="020B0609020000020004" pitchFamily="49" charset="0"/>
+              <a:solidFill>
+                <a:srgbClr val="2B2B2B"/>
+              </a:solidFill>
               <a:ea typeface="Cascadia Mono" panose="020B0609020000020004" pitchFamily="49" charset="0"/>
               <a:cs typeface="Cascadia Mono" panose="020B0609020000020004" pitchFamily="49" charset="0"/>
             </a:endParaRPr>
@@ -13462,64 +13559,6 @@
           </a:p>
         </p:txBody>
       </p:sp>
-      <p:sp>
-        <p:nvSpPr>
-          <p:cNvPr id="14" name="Shape 11"/>
-          <p:cNvSpPr/>
-          <p:nvPr/>
-        </p:nvSpPr>
-        <p:spPr>
-          <a:xfrm>
-            <a:off x="10351008" y="5340096"/>
-            <a:ext cx="923544" cy="923544"/>
-          </a:xfrm>
-          <a:prstGeom prst="roundRect">
-            <a:avLst>
-              <a:gd name="adj" fmla="val 5941"/>
-            </a:avLst>
-          </a:prstGeom>
-          <a:solidFill>
-            <a:srgbClr val="FFFFFF"/>
-          </a:solidFill>
-          <a:ln w="15875">
-            <a:solidFill>
-              <a:srgbClr val="1F3D2C"/>
-            </a:solidFill>
-            <a:prstDash val="solid"/>
-          </a:ln>
-        </p:spPr>
-        <p:txBody>
-          <a:bodyPr/>
-          <a:lstStyle/>
-          <a:p>
-            <a:endParaRPr lang="en-US"/>
-          </a:p>
-        </p:txBody>
-      </p:sp>
-      <p:pic>
-        <p:nvPicPr>
-          <p:cNvPr id="15" name="Image 1" descr="/home/claude/pptx-build/assets/qr-sec3-ado2gh.png"/>
-          <p:cNvPicPr>
-            <a:picLocks noChangeAspect="1"/>
-          </p:cNvPicPr>
-          <p:nvPr/>
-        </p:nvPicPr>
-        <p:blipFill>
-          <a:blip r:embed="rId4"/>
-          <a:stretch>
-            <a:fillRect/>
-          </a:stretch>
-        </p:blipFill>
-        <p:spPr>
-          <a:xfrm>
-            <a:off x="10424160" y="5413248"/>
-            <a:ext cx="777240" cy="777240"/>
-          </a:xfrm>
-          <a:prstGeom prst="rect">
-            <a:avLst/>
-          </a:prstGeom>
-        </p:spPr>
-      </p:pic>
       <p:sp>
         <p:nvSpPr>
           <p:cNvPr id="16" name="Slide Number Placeholder"/>
@@ -14595,7 +14634,7 @@
               <a:buNone/>
             </a:pPr>
             <a:r>
-              <a:rPr lang="en-US" sz="1450" b="0" dirty="0">
+              <a:rPr lang="en-US" sz="1600" b="0" dirty="0">
                 <a:solidFill>
                   <a:srgbClr val="F5F5F0"/>
                 </a:solidFill>
@@ -14613,7 +14652,7 @@
               <a:buChar char="•"/>
             </a:pPr>
             <a:r>
-              <a:rPr lang="en-US" sz="1450" b="0" dirty="0">
+              <a:rPr lang="en-US" sz="1600" b="0" dirty="0">
                 <a:solidFill>
                   <a:srgbClr val="F5F5F0"/>
                 </a:solidFill>
@@ -14631,7 +14670,7 @@
               <a:buChar char="•"/>
             </a:pPr>
             <a:r>
-              <a:rPr lang="en-US" sz="1450" b="0" dirty="0">
+              <a:rPr lang="en-US" sz="1600" b="0" dirty="0">
                 <a:solidFill>
                   <a:srgbClr val="F5F5F0"/>
                 </a:solidFill>
@@ -14649,7 +14688,7 @@
               <a:buChar char="•"/>
             </a:pPr>
             <a:r>
-              <a:rPr lang="en-US" sz="1450" b="0" dirty="0">
+              <a:rPr lang="en-US" sz="1600" b="0" dirty="0">
                 <a:solidFill>
                   <a:srgbClr val="F5F5F0"/>
                 </a:solidFill>
@@ -14667,7 +14706,7 @@
               <a:buChar char="•"/>
             </a:pPr>
             <a:r>
-              <a:rPr lang="en-US" sz="1450" b="0" dirty="0">
+              <a:rPr lang="en-US" sz="1600" b="0" dirty="0">
                 <a:solidFill>
                   <a:srgbClr val="F5F5F0"/>
                 </a:solidFill>
@@ -14685,7 +14724,7 @@
               <a:buChar char="•"/>
             </a:pPr>
             <a:r>
-              <a:rPr lang="en-US" sz="1450" b="0" dirty="0">
+              <a:rPr lang="en-US" sz="1600" b="0" dirty="0">
                 <a:solidFill>
                   <a:srgbClr val="F5F5F0"/>
                 </a:solidFill>
@@ -14703,7 +14742,7 @@
               <a:buChar char="•"/>
             </a:pPr>
             <a:r>
-              <a:rPr lang="en-US" sz="1450" b="0" dirty="0">
+              <a:rPr lang="en-US" sz="1600" b="0" dirty="0">
                 <a:solidFill>
                   <a:srgbClr val="F5F5F0"/>
                 </a:solidFill>
@@ -14711,7 +14750,7 @@
               </a:rPr>
               <a:t>owner for migration failures</a:t>
             </a:r>
-            <a:endParaRPr lang="en-US" sz="1500" dirty="0"/>
+            <a:endParaRPr lang="en-US" sz="1600" dirty="0"/>
           </a:p>
         </p:txBody>
       </p:sp>

</xml_diff>

<commit_message>
Update readme to include feedback link (+ cleanup)
</commit_message>
<xml_diff>
--- a/presentation/azure-devops-to-github-the-great-migration-FULL-DECK.pptx
+++ b/presentation/azure-devops-to-github-the-great-migration-FULL-DECK.pptx
@@ -1399,8 +1399,13 @@
           <a:p>
             <a:r>
               <a:rPr lang="en-US" dirty="0"/>
-              <a:t>Standard sponsor-thanks slide — event organizer will tell you if this is required and what logos go here. Placeholder only; swap in real sponsor logos once the summit sends them.</a:t>
-            </a:r>
+              <a:t>Standard </a:t>
+            </a:r>
+            <a:r>
+              <a:rPr lang="en-US"/>
+              <a:t>sponsor-thanks slide</a:t>
+            </a:r>
+            <a:endParaRPr lang="en-US" dirty="0"/>
           </a:p>
         </p:txBody>
       </p:sp>
@@ -11289,125 +11294,6 @@
       </p:grpSpPr>
       <p:sp>
         <p:nvSpPr>
-          <p:cNvPr id="2" name="Text 0"/>
-          <p:cNvSpPr txBox="1"/>
-          <p:nvPr/>
-        </p:nvSpPr>
-        <p:spPr>
-          <a:xfrm>
-            <a:off x="548640" y="502920"/>
-            <a:ext cx="10515600" cy="685800"/>
-          </a:xfrm>
-          <a:prstGeom prst="rect">
-            <a:avLst/>
-          </a:prstGeom>
-          <a:noFill/>
-          <a:ln/>
-        </p:spPr>
-        <p:txBody>
-          <a:bodyPr wrap="square" lIns="0" tIns="0" rIns="0" bIns="0" rtlCol="0" anchor="ctr"/>
-          <a:lstStyle/>
-          <a:p>
-            <a:pPr marL="0" indent="0">
-              <a:buNone/>
-            </a:pPr>
-            <a:r>
-              <a:rPr lang="en-US" sz="3200" b="1" dirty="0">
-                <a:solidFill>
-                  <a:srgbClr val="1F3D2C"/>
-                </a:solidFill>
-                <a:latin typeface="Cambria" pitchFamily="34" charset="0"/>
-                <a:ea typeface="Cambria" pitchFamily="34" charset="-122"/>
-                <a:cs typeface="Cambria" pitchFamily="34" charset="-120"/>
-              </a:rPr>
-              <a:t>Thank You to Our Sponsors</a:t>
-            </a:r>
-            <a:endParaRPr lang="en-US" sz="3200" dirty="0"/>
-          </a:p>
-        </p:txBody>
-      </p:sp>
-      <p:sp>
-        <p:nvSpPr>
-          <p:cNvPr id="3" name="Shape 1"/>
-          <p:cNvSpPr/>
-          <p:nvPr/>
-        </p:nvSpPr>
-        <p:spPr>
-          <a:xfrm>
-            <a:off x="548640" y="1645920"/>
-            <a:ext cx="11064240" cy="3931920"/>
-          </a:xfrm>
-          <a:prstGeom prst="roundRect">
-            <a:avLst>
-              <a:gd name="adj" fmla="val 2791"/>
-            </a:avLst>
-          </a:prstGeom>
-          <a:solidFill>
-            <a:srgbClr val="F7F6F2"/>
-          </a:solidFill>
-          <a:ln w="12700">
-            <a:solidFill>
-              <a:srgbClr val="DDD8CC"/>
-            </a:solidFill>
-            <a:prstDash val="solid"/>
-          </a:ln>
-          <a:effectLst>
-            <a:outerShdw blurRad="76200" dist="25400" dir="5400000" algn="bl" rotWithShape="0">
-              <a:srgbClr val="000000">
-                <a:alpha val="12000"/>
-              </a:srgbClr>
-            </a:outerShdw>
-          </a:effectLst>
-        </p:spPr>
-        <p:txBody>
-          <a:bodyPr/>
-          <a:lstStyle/>
-          <a:p>
-            <a:endParaRPr lang="en-US"/>
-          </a:p>
-        </p:txBody>
-      </p:sp>
-      <p:sp>
-        <p:nvSpPr>
-          <p:cNvPr id="4" name="Text 2"/>
-          <p:cNvSpPr txBox="1"/>
-          <p:nvPr/>
-        </p:nvSpPr>
-        <p:spPr>
-          <a:xfrm>
-            <a:off x="914400" y="3200400"/>
-            <a:ext cx="10332720" cy="640080"/>
-          </a:xfrm>
-          <a:prstGeom prst="rect">
-            <a:avLst/>
-          </a:prstGeom>
-          <a:noFill/>
-          <a:ln/>
-        </p:spPr>
-        <p:txBody>
-          <a:bodyPr wrap="square" lIns="0" tIns="0" rIns="0" bIns="0" rtlCol="0" anchor="ctr"/>
-          <a:lstStyle/>
-          <a:p>
-            <a:pPr marL="0" indent="0" algn="ctr">
-              <a:buNone/>
-            </a:pPr>
-            <a:r>
-              <a:rPr lang="en-US" sz="2000" i="1" dirty="0">
-                <a:solidFill>
-                  <a:srgbClr val="6B6B63"/>
-                </a:solidFill>
-                <a:latin typeface="Calibri" pitchFamily="34" charset="0"/>
-                <a:ea typeface="Calibri" pitchFamily="34" charset="-122"/>
-                <a:cs typeface="Calibri" pitchFamily="34" charset="-120"/>
-              </a:rPr>
-              <a:t>[PLACEHOLDER — drop in actual sponsor logos before the talk]</a:t>
-            </a:r>
-            <a:endParaRPr lang="en-US" sz="2000" dirty="0"/>
-          </a:p>
-        </p:txBody>
-      </p:sp>
-      <p:sp>
-        <p:nvSpPr>
           <p:cNvPr id="5" name="Slide Number Placeholder"/>
           <p:cNvSpPr>
             <a:spLocks noGrp="1"/>
@@ -11429,6 +11315,36 @@
           </a:p>
         </p:txBody>
       </p:sp>
+      <p:pic>
+        <p:nvPicPr>
+          <p:cNvPr id="7" name="Picture 6">
+            <a:extLst>
+              <a:ext uri="{FF2B5EF4-FFF2-40B4-BE49-F238E27FC236}">
+                <a16:creationId xmlns:a16="http://schemas.microsoft.com/office/drawing/2014/main" id="{62312F7A-D149-7F69-75D6-2B4AA23FC0C3}"/>
+              </a:ext>
+            </a:extLst>
+          </p:cNvPr>
+          <p:cNvPicPr>
+            <a:picLocks noChangeAspect="1"/>
+          </p:cNvPicPr>
+          <p:nvPr/>
+        </p:nvPicPr>
+        <p:blipFill>
+          <a:blip r:embed="rId3"/>
+          <a:stretch>
+            <a:fillRect/>
+          </a:stretch>
+        </p:blipFill>
+        <p:spPr>
+          <a:xfrm>
+            <a:off x="0" y="0"/>
+            <a:ext cx="12192000" cy="6858000"/>
+          </a:xfrm>
+          <a:prstGeom prst="rect">
+            <a:avLst/>
+          </a:prstGeom>
+        </p:spPr>
+      </p:pic>
     </p:spTree>
   </p:cSld>
   <p:clrMapOvr>

</xml_diff>

<commit_message>
Add timings to slides
</commit_message>
<xml_diff>
--- a/presentation/azure-devops-to-github-the-great-migration-FULL-DECK.pptx
+++ b/presentation/azure-devops-to-github-the-great-migration-FULL-DECK.pptx
@@ -332,6 +332,23 @@
           <a:lstStyle/>
           <a:p>
             <a:r>
+              <a:rPr lang="en-US" b="1" dirty="0"/>
+              <a:t>TIMING: </a:t>
+            </a:r>
+            <a:r>
+              <a:rPr lang="en-US" b="1"/>
+              <a:t>budget 0:15 </a:t>
+            </a:r>
+            <a:r>
+              <a:rPr lang="en-US" b="1" dirty="0"/>
+              <a:t>for this slide (cum 0:00-0:15 of 90:00).</a:t>
+            </a:r>
+          </a:p>
+          <a:p>
+            <a:endParaRPr lang="en-US" b="1" dirty="0"/>
+          </a:p>
+          <a:p>
+            <a:r>
               <a:rPr lang="en-US" dirty="0"/>
               <a:t>Open cold — no 'hi, I'm Kevin' throat-clearing. Let the title sit for a beat, then deliver the tagline in the documentary voice (calm, declarative, faintly awed — never winking). That's the only line spoken in that register on this slide; the rest of the intro is normal conference delivery. This sets up the conceit for the whole talk: six section-opener cards plus a closer, all in this voice, everything else played straight.</a:t>
             </a:r>
@@ -418,6 +435,33 @@
           <a:bodyPr/>
           <a:lstStyle/>
           <a:p>
+            <a:pPr marL="0" marR="0" lvl="0" indent="0" algn="l" defTabSz="914400" rtl="0" eaLnBrk="1" fontAlgn="auto" latinLnBrk="0" hangingPunct="1">
+              <a:lnSpc>
+                <a:spcPct val="100000"/>
+              </a:lnSpc>
+              <a:spcBef>
+                <a:spcPts val="0"/>
+              </a:spcBef>
+              <a:spcAft>
+                <a:spcPts val="0"/>
+              </a:spcAft>
+              <a:buClrTx/>
+              <a:buSzTx/>
+              <a:buFontTx/>
+              <a:buNone/>
+              <a:tabLst/>
+              <a:defRPr/>
+            </a:pPr>
+            <a:r>
+              <a:rPr lang="en-US" b="1" dirty="0"/>
+              <a:t>TIMING: budget 1:45 for this slide (cum 10:25-12:10 of 90:00).</a:t>
+            </a:r>
+            <a:endParaRPr dirty="0"/>
+          </a:p>
+          <a:p>
+            <a:endParaRPr dirty="0"/>
+          </a:p>
+          <a:p>
             <a:r>
               <a:rPr dirty="0"/>
               <a:t>Straight delivery. Git is Git, so commit history is easy, and pull requests plus most branch policies migrate without much drama through GitHub Enterprise Importer.</a:t>
@@ -535,8 +579,21 @@
           <a:lstStyle/>
           <a:p>
             <a:r>
+              <a:rPr lang="en-US" b="1" dirty="0"/>
+              <a:t>TIMING: budget 1:45 for this slide (cum 12:10-13:55 of 90:00).</a:t>
+            </a:r>
+          </a:p>
+          <a:p>
+            <a:endParaRPr lang="en-US" b="1" dirty="0"/>
+          </a:p>
+          <a:p>
+            <a:r>
               <a:rPr dirty="0"/>
-              <a:t>Straight delivery, quick. Both wikis are Git repos, so the pages themselves copy with a clone and a push. The work is everything the Azure DevOps wiki layered on top: .order files and nested folders set page order and hierarchy, and GitHub’s wiki doesn’t read .order and shows a flat page list; Azure DevOps-only markdown ([[_TOC_]], ::: mermaid blocks, #123 work-item links, @mentions) renders as plain text or breaks; attachments live in a .attachments folder that page links point into.</a:t>
+              <a:t>Straight delivery, quick. Both wikis are Git repos, so the pages themselves copy with a clone and a push. The work is everything the Azure DevOps wiki layered on top: .order files and nested folders set page order and hierarchy, and GitHub’s wiki doesn’t read .order and shows a flat page list</a:t>
+            </a:r>
+            <a:r>
+              <a:rPr lang="en-US" dirty="0"/>
+              <a:t>.</a:t>
             </a:r>
           </a:p>
           <a:p>
@@ -634,6 +691,15 @@
           <a:lstStyle/>
           <a:p>
             <a:r>
+              <a:rPr lang="en-US" b="1"/>
+              <a:t>TIMING: budget 1:45 for this slide (cum 13:55-15:40 of 90:00).</a:t>
+            </a:r>
+          </a:p>
+          <a:p>
+            <a:endParaRPr lang="en-US" b="1"/>
+          </a:p>
+          <a:p>
+            <a:r>
               <a:t>Straight delivery. Unlike Repos or Wiki, this one isn't a clean migration path — it's a genuine three-way decision: keep Azure Artifacts as-is, move fully to GitHub Packages, or dual-publish during a transition window. The realistic PoC target for most enterprises is the first option done well: GitHub Actions publishing to and consuming from an existing Azure Artifacts feed, because repointing every downstream consumer at cutover usually isn't realistic. This is a decision, not a rewrite — say that line plainly, it's the slide's title for a reason.</a:t>
             </a:r>
           </a:p>
@@ -728,6 +794,15 @@
           <a:lstStyle/>
           <a:p>
             <a:r>
+              <a:rPr lang="en-US" b="1"/>
+              <a:t>TIMING: budget 2:05 for this slide (cum 15:40-17:45 of 90:00).</a:t>
+            </a:r>
+          </a:p>
+          <a:p>
+            <a:endParaRPr lang="en-US" b="1"/>
+          </a:p>
+          <a:p>
+            <a:r>
               <a:t>Straight delivery, and lead with the correction rather than burying it: GitHub does not ship a DORA dashboard.</a:t>
             </a:r>
           </a:p>
@@ -830,6 +905,15 @@
           <a:lstStyle/>
           <a:p>
             <a:r>
+              <a:rPr lang="en-US" b="1"/>
+              <a:t>TIMING: budget 1:05 for this slide (cum 17:45-18:50 of 90:00).</a:t>
+            </a:r>
+          </a:p>
+          <a:p>
+            <a:endParaRPr lang="en-US" b="1"/>
+          </a:p>
+          <a:p>
+            <a:r>
               <a:rPr lang="en-US" dirty="0"/>
               <a:t>Straight delivery, deliberately slow — this line is the whole talk in one sentence, worth letting it land before moving on. Everything that's file-based and version-controlled — repos, wiki — travels cleanly because Git is Git on both sides. Everything backed by a proprietary database with its own data model — dashboards here, and Boards plus Test Plans in the next section — needs either a rewrite, a decision, or in Test Plans' case, doesn't come at all. This sets up sections 3 and 4 directly.</a:t>
             </a:r>
@@ -917,6 +1001,15 @@
           <a:lstStyle/>
           <a:p>
             <a:r>
+              <a:rPr lang="en-US" b="1"/>
+              <a:t>TIMING: budget 2:10 for this slide (cum 18:50-21:00 of 90:00).</a:t>
+            </a:r>
+          </a:p>
+          <a:p>
+            <a:endParaRPr lang="en-US" b="1"/>
+          </a:p>
+          <a:p>
+            <a:r>
               <a:t>Straight delivery, land this one deliberately — it’s the thesis the whole talk hangs on. Three audiences, one pattern: developers move to GitHub and get Copilot and Actions; managers keep Azure Boards, capacity charts and Power BI exactly as they are; and the budget conversation starts easier because GitHub Enterprise Cloud includes Azure DevOps Basic access for users who sign in with Entra ID.</a:t>
             </a:r>
           </a:p>
@@ -1027,6 +1120,15 @@
           <a:lstStyle/>
           <a:p>
             <a:r>
+              <a:rPr lang="en-US" b="1"/>
+              <a:t>TIMING: budget 1:00 for this slide (cum 21:00-22:00 of 90:00).</a:t>
+            </a:r>
+          </a:p>
+          <a:p>
+            <a:endParaRPr lang="en-US" b="1"/>
+          </a:p>
+          <a:p>
+            <a:r>
               <a:t>Brief check-in, not a discussion window — about a minute. Take one quick question if a hand is up, otherwise move straight into section 3. The real Q&amp;A time is banked for the open Q&amp;A at the end.</a:t>
             </a:r>
           </a:p>
@@ -1113,6 +1215,15 @@
           <a:lstStyle/>
           <a:p>
             <a:r>
+              <a:rPr lang="en-US" b="1"/>
+              <a:t>TIMING: budget 0:25 for this slide (cum 22:00-22:25 of 90:00).</a:t>
+            </a:r>
+          </a:p>
+          <a:p>
+            <a:endParaRPr lang="en-US" b="1"/>
+          </a:p>
+          <a:p>
+            <a:r>
               <a:rPr lang="en-US"/>
               <a:t>DOCUMENTARY VOICE — deliver slowly and deadpan. The new metaphor introduces three migration planes: repository data, automation, and validation. Pause, then return to straight technical delivery. This is the heaviest section, so keep the framing concise.</a:t>
             </a:r>
@@ -1200,6 +1311,15 @@
           <a:lstStyle/>
           <a:p>
             <a:r>
+              <a:rPr lang="en-US" b="1"/>
+              <a:t>TIMING: budget 1:35 for this slide (cum 22:25-24:00 of 90:00).</a:t>
+            </a:r>
+          </a:p>
+          <a:p>
+            <a:endParaRPr lang="en-US" b="1"/>
+          </a:p>
+          <a:p>
+            <a:r>
               <a:rPr dirty="0"/>
               <a:t>Straight delivery, and take this one slowly — the rest of the section depends on the distinction.</a:t>
             </a:r>
@@ -1305,6 +1425,15 @@
           <a:lstStyle/>
           <a:p>
             <a:r>
+              <a:rPr lang="en-US" b="1"/>
+              <a:t>TIMING: budget 1:35 for this slide (cum 24:00-25:35 of 90:00).</a:t>
+            </a:r>
+          </a:p>
+          <a:p>
+            <a:endParaRPr lang="en-US" b="1"/>
+          </a:p>
+          <a:p>
+            <a:r>
               <a:rPr lang="en-US" dirty="0"/>
               <a:t>Straight delivery. Read by row, not by column. Repository data uses GEI or ELM but still needs human decisions and troubleshooting. Automation uses Actions Importer plus engineering and AI reasoning. Validation uses deterministic evidence and accountable human decisions; AI can assist but cannot declare the migration complete.</a:t>
             </a:r>
@@ -1391,15 +1520,36 @@
           <a:bodyPr/>
           <a:lstStyle/>
           <a:p>
+            <a:pPr marL="0" marR="0" lvl="0" indent="0" algn="l" defTabSz="914400" rtl="0" eaLnBrk="1" fontAlgn="auto" latinLnBrk="0" hangingPunct="1">
+              <a:lnSpc>
+                <a:spcPct val="100000"/>
+              </a:lnSpc>
+              <a:spcBef>
+                <a:spcPts val="0"/>
+              </a:spcBef>
+              <a:spcAft>
+                <a:spcPts val="0"/>
+              </a:spcAft>
+              <a:buClrTx/>
+              <a:buSzTx/>
+              <a:buFontTx/>
+              <a:buNone/>
+              <a:tabLst/>
+              <a:defRPr/>
+            </a:pPr>
+            <a:r>
+              <a:rPr lang="en-US" b="1" dirty="0"/>
+              <a:t>TIMING: budget 0:30 for this slide (cum 0:15-0:45 of 90:00).</a:t>
+            </a:r>
+          </a:p>
+          <a:p>
+            <a:endParaRPr lang="en-US" dirty="0"/>
+          </a:p>
+          <a:p>
             <a:r>
               <a:rPr lang="en-US" dirty="0"/>
-              <a:t>Standard </a:t>
-            </a:r>
-            <a:r>
-              <a:rPr lang="en-US"/>
-              <a:t>sponsor-thanks slide</a:t>
-            </a:r>
-            <a:endParaRPr lang="en-US" dirty="0"/>
+              <a:t>Standard sponsor-thanks slide</a:t>
+            </a:r>
           </a:p>
         </p:txBody>
       </p:sp>
@@ -1484,6 +1634,15 @@
           <a:lstStyle/>
           <a:p>
             <a:r>
+              <a:rPr lang="en-US" b="1"/>
+              <a:t>TIMING: budget 1:15 for this slide (cum 25:35-26:50 of 90:00).</a:t>
+            </a:r>
+          </a:p>
+          <a:p>
+            <a:endParaRPr lang="en-US" b="1"/>
+          </a:p>
+          <a:p>
+            <a:r>
               <a:rPr dirty="0"/>
               <a:t>Straight delivery. Spend twenty seconds getting the naming right, because the docs don't and everyone who goes looking afterwards hits the same confusion.</a:t>
             </a:r>
@@ -1580,6 +1739,15 @@
           <a:lstStyle/>
           <a:p>
             <a:r>
+              <a:rPr lang="en-US" b="1"/>
+              <a:t>TIMING: budget 1:35 for this slide (cum 26:50-28:25 of 90:00).</a:t>
+            </a:r>
+          </a:p>
+          <a:p>
+            <a:endParaRPr lang="en-US" b="1"/>
+          </a:p>
+          <a:p>
+            <a:r>
               <a:rPr lang="en-US" dirty="0"/>
               <a:t>Straight delivery. Briefly mention it, but don’t spend much time on it. </a:t>
             </a:r>
@@ -1742,6 +1910,15 @@
           <a:lstStyle/>
           <a:p>
             <a:r>
+              <a:rPr lang="en-US" b="1"/>
+              <a:t>TIMING: budget 1:55 for this slide (cum 28:25-30:20 of 90:00).</a:t>
+            </a:r>
+          </a:p>
+          <a:p>
+            <a:endParaRPr lang="en-US" b="1"/>
+          </a:p>
+          <a:p>
+            <a:r>
               <a:rPr dirty="0"/>
               <a:t>Straight delivery. Keep the non-negotiable order: install the Azure Pipelines GitHub App first and plan identity mapping before mannequins are created. Also decide account model, team structure, repository naming and visibility, system-of-record during transition, change freeze or reconciliation, and failure ownership before the first production run.</a:t>
             </a:r>
@@ -1838,6 +2015,15 @@
           <a:lstStyle/>
           <a:p>
             <a:r>
+              <a:rPr lang="en-US" b="1"/>
+              <a:t>TIMING: budget 1:55 for this slide (cum 30:20-32:15 of 90:00).</a:t>
+            </a:r>
+          </a:p>
+          <a:p>
+            <a:endParaRPr lang="en-US" b="1"/>
+          </a:p>
+          <a:p>
+            <a:r>
               <a:rPr dirty="0"/>
               <a:t>Straight delivery. This is the automation-plane tool. The audit breakdown is the planning artifact: it turns “this looks hard” into a backlog with counts.</a:t>
             </a:r>
@@ -2071,6 +2257,15 @@
           <a:lstStyle/>
           <a:p>
             <a:r>
+              <a:rPr lang="en-US" b="1"/>
+              <a:t>TIMING: budget 2:35 for this slide (cum 32:15-34:50 of 90:00).</a:t>
+            </a:r>
+          </a:p>
+          <a:p>
+            <a:endParaRPr lang="en-US" b="1"/>
+          </a:p>
+          <a:p>
+            <a:r>
               <a:rPr dirty="0"/>
               <a:t>Open the slide with the line: “Both platforms use YAML, in the same way that Java and JavaScript both contain the word ‘Java.’” It is also in the session abstract, so deliver it as a callback. It gets the laugh and it is the slide’s entire thesis: same syntax, different language. Say it once and move on.</a:t>
             </a:r>
@@ -2191,6 +2386,15 @@
           <a:lstStyle/>
           <a:p>
             <a:r>
+              <a:rPr lang="en-US" b="1"/>
+              <a:t>TIMING: budget 3:25 for this slide (cum 34:50-38:15 of 90:00).</a:t>
+            </a:r>
+          </a:p>
+          <a:p>
+            <a:endParaRPr lang="en-US" b="1"/>
+          </a:p>
+          <a:p>
+            <a:r>
               <a:rPr dirty="0"/>
               <a:t>Straight delivery, and slow down here — for an enterprise room this is the slide that separates a migration talk from a migration.</a:t>
             </a:r>
@@ -2312,6 +2516,15 @@
         <p:txBody>
           <a:bodyPr/>
           <a:lstStyle/>
+          <a:p>
+            <a:r>
+              <a:rPr lang="en-US" b="1"/>
+              <a:t>TIMING: budget 1:15 for this slide (cum 38:15-39:30 of 90:00).</a:t>
+            </a:r>
+          </a:p>
+          <a:p>
+            <a:endParaRPr lang="en-US" b="1"/>
+          </a:p>
           <a:p>
             <a:r>
               <a:rPr lang="en-US"/>
@@ -2401,6 +2614,15 @@
           <a:lstStyle/>
           <a:p>
             <a:r>
+              <a:rPr lang="en-US" b="1"/>
+              <a:t>TIMING: budget 1:55 for this slide (cum 39:30-41:25 of 90:00).</a:t>
+            </a:r>
+          </a:p>
+          <a:p>
+            <a:endParaRPr lang="en-US" b="1"/>
+          </a:p>
+          <a:p>
+            <a:r>
               <a:t>Straight delivery. Walk the five steps across all three planes. Inventory before moving; trial-migrate repository data; rebuild automation semantics and the execution environment; prove equivalence and deployability; then cut over with monitoring and rollback ready.</a:t>
             </a:r>
           </a:p>
@@ -2495,6 +2717,15 @@
           <a:lstStyle/>
           <a:p>
             <a:r>
+              <a:rPr lang="en-US" b="1"/>
+              <a:t>TIMING: budget 1:35 for this slide (cum 41:25-43:00 of 90:00).</a:t>
+            </a:r>
+          </a:p>
+          <a:p>
+            <a:endParaRPr lang="en-US" b="1"/>
+          </a:p>
+          <a:p>
+            <a:r>
               <a:t>Straight delivery. This is a reusable acceptance checklist — tell the room to photograph it, it is the most portable thing in the talk.</a:t>
             </a:r>
           </a:p>
@@ -2589,6 +2820,15 @@
           <a:lstStyle/>
           <a:p>
             <a:r>
+              <a:rPr lang="en-US" b="1"/>
+              <a:t>TIMING: budget 1:00 for this slide (cum 43:00-44:00 of 90:00).</a:t>
+            </a:r>
+          </a:p>
+          <a:p>
+            <a:endParaRPr lang="en-US" b="1"/>
+          </a:p>
+          <a:p>
+            <a:r>
               <a:t>Brief check-in, not a discussion window — about 30 seconds given how much ground this section covers. Take one quick question if a hand is up, otherwise move straight into section 4. The real Q&amp;A time is banked for the open Q&amp;A at the end.</a:t>
             </a:r>
           </a:p>
@@ -2675,6 +2915,15 @@
           <a:lstStyle/>
           <a:p>
             <a:r>
+              <a:rPr lang="en-US" b="1"/>
+              <a:t>TIMING: budget 0:50 for this slide (cum 0:45-1:35 of 90:00).</a:t>
+            </a:r>
+          </a:p>
+          <a:p>
+            <a:endParaRPr lang="en-US" b="1"/>
+          </a:p>
+          <a:p>
+            <a:r>
               <a:t>Straight delivery. Walk the six legs quickly. Budget for the 90-minute slot: section 1 about 8 minutes (including the opening), section 2 about 13, section 3 about 21, section 4 about 10, section 5 about 12, section 6 about 8. That is roughly 72 minutes of content plus four one-minute Q&amp;A pockets, which leaves about 14 minutes of open Q&amp;A on the thank-you slide. Section 3 includes the ELM slide; give it a few seconds and move on.</a:t>
             </a:r>
           </a:p>
@@ -2769,6 +3018,15 @@
           <a:lstStyle/>
           <a:p>
             <a:r>
+              <a:rPr lang="en-US" b="1"/>
+              <a:t>TIMING: budget 0:25 for this slide (cum 44:00-44:25 of 90:00).</a:t>
+            </a:r>
+          </a:p>
+          <a:p>
+            <a:endParaRPr lang="en-US" b="1"/>
+          </a:p>
+          <a:p>
+            <a:r>
               <a:t>DOCUMENTARY VOICE — the only register for this slide. Deliver slowly, deadpan, faintly awed, same conceit as the earlier section openers. Pause after the line, then go straight back to normal delivery for the Boards-vs-Projects framing slide. Keep this section brisk: five slides, and the payoff is the Test Plans slide and the recommendation, not length.</a:t>
             </a:r>
           </a:p>
@@ -2855,6 +3113,15 @@
           <a:lstStyle/>
           <a:p>
             <a:r>
+              <a:rPr lang="en-US" b="1"/>
+              <a:t>TIMING: budget 2:00 for this slide (cum 44:25-46:25 of 90:00).</a:t>
+            </a:r>
+          </a:p>
+          <a:p>
+            <a:endParaRPr lang="en-US" b="1"/>
+          </a:p>
+          <a:p>
+            <a:r>
               <a:rPr dirty="0"/>
               <a:t>Straight delivery. Frame this before comparing feature by feature — Azure Boards and GitHub Projects are not two competitors in one category, they are two different models.</a:t>
             </a:r>
@@ -2969,6 +3236,15 @@
           <a:lstStyle/>
           <a:p>
             <a:r>
+              <a:rPr lang="en-US" b="1"/>
+              <a:t>TIMING: budget 2:25 for this slide (cum 46:25-48:50 of 90:00).</a:t>
+            </a:r>
+          </a:p>
+          <a:p>
+            <a:endParaRPr lang="en-US" b="1"/>
+          </a:p>
+          <a:p>
+            <a:r>
               <a:t>Straight delivery. Take each tool on its own terms before comparing what a migration loses.</a:t>
             </a:r>
           </a:p>
@@ -3079,6 +3355,15 @@
           <a:lstStyle/>
           <a:p>
             <a:r>
+              <a:rPr lang="en-US" b="1"/>
+              <a:t>TIMING: budget 2:15 for this slide (cum 48:50-51:05 of 90:00).</a:t>
+            </a:r>
+          </a:p>
+          <a:p>
+            <a:endParaRPr lang="en-US" b="1"/>
+          </a:p>
+          <a:p>
+            <a:r>
               <a:t>Straight delivery. Be concrete about the loss: sprint history and capacity data, custom process fields and rules, the process template itself, and the Project / Team / Area Path structure have no clean landing spot in GitHub Projects. Parent-child links are the exception; they can map to sub-issues, which go up to eight levels deep.</a:t>
             </a:r>
           </a:p>
@@ -3181,6 +3466,15 @@
           <a:lstStyle/>
           <a:p>
             <a:r>
+              <a:rPr lang="en-US" b="1"/>
+              <a:t>TIMING: budget 0:40 for this slide (cum 51:05-51:45 of 90:00).</a:t>
+            </a:r>
+          </a:p>
+          <a:p>
+            <a:endParaRPr lang="en-US" b="1"/>
+          </a:p>
+          <a:p>
+            <a:r>
               <a:rPr lang="en-US" dirty="0"/>
               <a:t>Straight delivery, and let this one land plainly — it's probably the best-received slide in the whole deck precisely because it doesn't try to spin anything. </a:t>
             </a:r>
@@ -3277,6 +3571,15 @@
           <a:lstStyle/>
           <a:p>
             <a:r>
+              <a:rPr lang="en-US" b="1"/>
+              <a:t>TIMING: budget 2:15 for this slide (cum 51:45-54:00 of 90:00).</a:t>
+            </a:r>
+          </a:p>
+          <a:p>
+            <a:endParaRPr lang="en-US" b="1"/>
+          </a:p>
+          <a:p>
+            <a:r>
               <a:t>Straight delivery. This is the explicit takeaway for the section, and it is section 2’s hybrid pattern applied to planning: connect Azure Boards to your GitHub repos before touching anything else. Developers work in GitHub, next to Copilot and their pull requests; managers keep the sprint hub, capacity charts and Power BI reporting exactly where they are. The Azure Boards app for GitHub links commits and PRs back to work items with AB# mentions, and the Copilot cloud agent can be started from a Boards item.</a:t>
             </a:r>
           </a:p>
@@ -3379,6 +3682,15 @@
           <a:lstStyle/>
           <a:p>
             <a:r>
+              <a:rPr lang="en-US" b="1"/>
+              <a:t>TIMING: budget 1:00 for this slide (cum 54:00-55:00 of 90:00).</a:t>
+            </a:r>
+          </a:p>
+          <a:p>
+            <a:endParaRPr lang="en-US" b="1"/>
+          </a:p>
+          <a:p>
+            <a:r>
               <a:t>Brief check-in, not a discussion window — about a minute. Take one quick question if a hand is up, otherwise move straight into section 5. The real Q&amp;A time is banked for the open Q&amp;A at the end.</a:t>
             </a:r>
           </a:p>
@@ -3465,6 +3777,15 @@
           <a:lstStyle/>
           <a:p>
             <a:r>
+              <a:rPr lang="en-US" b="1"/>
+              <a:t>TIMING: budget 0:25 for this slide (cum 55:00-55:25 of 90:00).</a:t>
+            </a:r>
+          </a:p>
+          <a:p>
+            <a:endParaRPr lang="en-US" b="1"/>
+          </a:p>
+          <a:p>
+            <a:r>
               <a:rPr lang="en-US" dirty="0"/>
               <a:t>DOCUMENTARY VOICE — the only register for this slide. Deliver slowly, deadpan, faintly awed, same conceit as the earlier section openers. Pause after the line, then go straight back to normal delivery for the thesis slide. This section's closing slide comes back to this exact character — plant it here without over-explaining, the payoff lands later.</a:t>
             </a:r>
@@ -3552,6 +3873,15 @@
           <a:lstStyle/>
           <a:p>
             <a:r>
+              <a:rPr lang="en-US" b="1"/>
+              <a:t>TIMING: budget 1:30 for this slide (cum 55:25-56:55 of 90:00).</a:t>
+            </a:r>
+          </a:p>
+          <a:p>
+            <a:endParaRPr lang="en-US" b="1"/>
+          </a:p>
+          <a:p>
+            <a:r>
               <a:t>Straight delivery. This is the section’s thesis — land it early and come back to it. Most migrations that fail don’t fail in the converter; gh-ado2gh and Actions Importer do what they say. The execution-environment work from section 3 is real, but it is engineering you can plan. What sinks migrations is three predictable human failures: no real selection process (a choice made by momentum rather than evaluated on merit), customization starting before anyone understood the new tool, and a rollout that felt done TO people rather than WITH them. The rest of this section is about avoiding those three.</a:t>
             </a:r>
           </a:p>
@@ -3638,6 +3968,15 @@
           <a:lstStyle/>
           <a:p>
             <a:r>
+              <a:rPr lang="en-US" b="1"/>
+              <a:t>TIMING: budget 2:20 for this slide (cum 56:55-59:15 of 90:00).</a:t>
+            </a:r>
+          </a:p>
+          <a:p>
+            <a:endParaRPr lang="en-US" b="1"/>
+          </a:p>
+          <a:p>
+            <a:r>
               <a:t>Before walking the steps: “In most organizations the real selection process is that somebody senior used it at their last job.” OPTIONAL LAUGH LINE, and it is precisely failure mode one from the previous slide.</a:t>
             </a:r>
           </a:p>
@@ -3740,6 +4079,15 @@
           <a:lstStyle/>
           <a:p>
             <a:r>
+              <a:rPr lang="en-US" b="1"/>
+              <a:t>TIMING: budget 0:20 for this slide (cum 1:35-1:55 of 90:00).</a:t>
+            </a:r>
+          </a:p>
+          <a:p>
+            <a:endParaRPr lang="en-US" b="1"/>
+          </a:p>
+          <a:p>
+            <a:r>
               <a:t>DOCUMENTARY VOICE — the only register for this slide. Deliver slowly, deadpan, faintly awed. Do not wink at the joke. This is the first of six opener cards plus a closer — it establishes the conceit. Pause after delivering the line before moving on. The next slide goes straight back to normal delivery.</a:t>
             </a:r>
           </a:p>
@@ -3826,6 +4174,15 @@
           <a:lstStyle/>
           <a:p>
             <a:r>
+              <a:rPr lang="en-US" b="1"/>
+              <a:t>TIMING: budget 1:30 for this slide (cum 59:15-60:45 of 90:00).</a:t>
+            </a:r>
+          </a:p>
+          <a:p>
+            <a:endParaRPr lang="en-US" b="1"/>
+          </a:p>
+          <a:p>
+            <a:r>
               <a:rPr lang="en-US"/>
               <a:t>Straight delivery. Align the rollout with the three-plane model. Define authority and traceability first, prove one repository end-to-end, then scale in waves with explicit entry criteria. Cut over only with validation and rollback ready; decommission after long-tail checks, not immediately after migration.</a:t>
             </a:r>
@@ -3913,6 +4270,15 @@
           <a:lstStyle/>
           <a:p>
             <a:r>
+              <a:rPr lang="en-US" b="1"/>
+              <a:t>TIMING: budget 1:50 for this slide (cum 60:45-62:35 of 90:00).</a:t>
+            </a:r>
+          </a:p>
+          <a:p>
+            <a:endParaRPr lang="en-US" b="1"/>
+          </a:p>
+          <a:p>
+            <a:r>
               <a:t>Straight delivery. Sticker-price comparisons are the easiest way to make a bad decision look rigorous. Compare the whole bill: licensing tiers; GitHub Secret Protection and GitHub Code Security, which since April 2025 are sold as two separate add-ons rather than one Advanced Security bundle (Azure DevOps sells the same two products, so security alone doesn’t tip the decision); runner and compute minutes; and the real admin and migration effort, which is easy to leave off a spreadsheet entirely.</a:t>
             </a:r>
           </a:p>
@@ -4015,6 +4381,15 @@
           <a:lstStyle/>
           <a:p>
             <a:r>
+              <a:rPr lang="en-US" b="1" dirty="0"/>
+              <a:t>TIMING: budget 2:35 for this slide (cum 62:35-65:10 of 90:00).</a:t>
+            </a:r>
+          </a:p>
+          <a:p>
+            <a:endParaRPr lang="en-US" b="1" dirty="0"/>
+          </a:p>
+          <a:p>
+            <a:r>
               <a:rPr dirty="0"/>
               <a:t>Straight delivery. This is the counterweight to section 1. AI is the honest reason most teams are migrating — this slide is where you pay that argument down so it reads as analysis rather than a pitch. Frame the four as a to-do list, not as reasons to doubt the move.</a:t>
             </a:r>
@@ -4162,6 +4537,33 @@
           <a:bodyPr/>
           <a:lstStyle/>
           <a:p>
+            <a:pPr marL="0" marR="0" lvl="0" indent="0" algn="l" defTabSz="914400" rtl="0" eaLnBrk="1" fontAlgn="auto" latinLnBrk="0" hangingPunct="1">
+              <a:lnSpc>
+                <a:spcPct val="100000"/>
+              </a:lnSpc>
+              <a:spcBef>
+                <a:spcPts val="0"/>
+              </a:spcBef>
+              <a:spcAft>
+                <a:spcPts val="0"/>
+              </a:spcAft>
+              <a:buClrTx/>
+              <a:buSzTx/>
+              <a:buFontTx/>
+              <a:buNone/>
+              <a:tabLst/>
+              <a:defRPr/>
+            </a:pPr>
+            <a:r>
+              <a:rPr lang="en-US" b="1" dirty="0"/>
+              <a:t>TIMING: budget 2:35 for this slide (cum 65:10-67:00 of 90:00).</a:t>
+            </a:r>
+            <a:endParaRPr lang="en-US" dirty="0"/>
+          </a:p>
+          <a:p>
+            <a:endParaRPr lang="en-US" dirty="0"/>
+          </a:p>
+          <a:p>
             <a:r>
               <a:rPr dirty="0"/>
               <a:t>Documentary aside — same voice as the opener cards, played for a beat, then straight delivery resumes. This is the section's closing synthesis: startups and one-to-three-squad teams should just take GitHub Projects' lightweight fit, no enterprise overhead needed. Scaled agile, regulated industries, and multi-team portfolios are exactly where Azure Boards' hierarchy and reporting earn their keep. Mixed estates get the hybrid pattern, deliberately — a fit, not a compromise. </a:t>
@@ -4268,6 +4670,15 @@
           <a:lstStyle/>
           <a:p>
             <a:r>
+              <a:rPr lang="en-US" b="1"/>
+              <a:t>TIMING: budget 1:00 for this slide (cum 67:00-68:00 of 90:00).</a:t>
+            </a:r>
+          </a:p>
+          <a:p>
+            <a:endParaRPr lang="en-US" b="1"/>
+          </a:p>
+          <a:p>
+            <a:r>
               <a:t>Brief check-in, not a discussion window — about a minute. Take one quick question if a hand is up, otherwise move straight into section 6, the final section. The real Q&amp;A time is banked for the open Q&amp;A at the end.</a:t>
             </a:r>
           </a:p>
@@ -4354,6 +4765,15 @@
           <a:lstStyle/>
           <a:p>
             <a:r>
+              <a:rPr lang="en-US" b="1"/>
+              <a:t>TIMING: budget 0:25 for this slide (cum 68:00-68:25 of 90:00).</a:t>
+            </a:r>
+          </a:p>
+          <a:p>
+            <a:endParaRPr lang="en-US" b="1"/>
+          </a:p>
+          <a:p>
+            <a:r>
               <a:rPr lang="en-US" dirty="0"/>
               <a:t>DOCUMENTARY VOICE — spoken live, not read. This is the section opener: slow down, let the metaphor land. We are closing the loop on the "field guide to a new habitat" framing from the whole talk — this section is about what still limps back to the old watering hole after everyone else has moved on.</a:t>
             </a:r>
@@ -4441,6 +4861,15 @@
           <a:lstStyle/>
           <a:p>
             <a:r>
+              <a:rPr lang="en-US" b="1"/>
+              <a:t>TIMING: budget 1:50 for this slide (cum 68:25-70:15 of 90:00).</a:t>
+            </a:r>
+          </a:p>
+          <a:p>
+            <a:endParaRPr lang="en-US" b="1"/>
+          </a:p>
+          <a:p>
+            <a:r>
               <a:t>STRAIGHT delivery. This is the practical, checklist-voiced part of the section. The five rows are meant to be read as "here is where these hide" — invite the room to mentally add their own sixth row, because every org has one nobody else would guess.</a:t>
             </a:r>
           </a:p>
@@ -4527,6 +4956,15 @@
           <a:lstStyle/>
           <a:p>
             <a:r>
+              <a:rPr lang="en-US" b="1"/>
+              <a:t>TIMING: budget 2:20 for this slide (cum 70:15-72:35 of 90:00).</a:t>
+            </a:r>
+          </a:p>
+          <a:p>
+            <a:endParaRPr lang="en-US" b="1"/>
+          </a:p>
+          <a:p>
+            <a:r>
               <a:t>Two registers on this one slide. STRAIGHT for the top two cards — this is real mechanical risk, say it plainly.</a:t>
             </a:r>
           </a:p>
@@ -4637,6 +5075,15 @@
           <a:lstStyle/>
           <a:p>
             <a:r>
+              <a:rPr lang="en-US" b="1"/>
+              <a:t>TIMING: budget 1:35 for this slide (cum 72:35-74:10 of 90:00).</a:t>
+            </a:r>
+          </a:p>
+          <a:p>
+            <a:endParaRPr lang="en-US" b="1"/>
+          </a:p>
+          <a:p>
+            <a:r>
               <a:t>STRAIGHT delivery, briskly. For item three, recap the three planes and the cross-plane methods. For item five, reinforce that migration is an operating model: ownership, entry criteria, evidence, rollback, and decommissioning—not merely a tooling sequence.</a:t>
             </a:r>
           </a:p>
@@ -4731,6 +5178,15 @@
           <a:lstStyle/>
           <a:p>
             <a:r>
+              <a:rPr lang="en-US" b="1"/>
+              <a:t>TIMING: budget 1:50 for this slide (cum 74:10-76:00 of 90:00).</a:t>
+            </a:r>
+          </a:p>
+          <a:p>
+            <a:endParaRPr lang="en-US" b="1"/>
+          </a:p>
+          <a:p>
+            <a:r>
               <a:rPr dirty="0"/>
               <a:t>STRAIGHT delivery, and let it land quieter than anything around it. This is the deck's thesis in one sentence, and it now sits where it earns the most: the recap just handed them six things to remember, and this is the one thing to feel.</a:t>
             </a:r>
@@ -4852,6 +5308,15 @@
           <a:lstStyle/>
           <a:p>
             <a:r>
+              <a:rPr lang="en-US" b="1"/>
+              <a:t>TIMING: budget 2:35 for this slide (cum 1:55-4:30 of 90:00).</a:t>
+            </a:r>
+          </a:p>
+          <a:p>
+            <a:endParaRPr lang="en-US" b="1"/>
+          </a:p>
+          <a:p>
+            <a:r>
               <a:rPr dirty="0"/>
               <a:t>Straight delivery. Name the real reason teams migrate before the polite reasons: most of the agentic Copilot work (cloud agent, agentic code review, agentic </a:t>
             </a:r>
@@ -5051,6 +5516,15 @@
           <a:lstStyle/>
           <a:p>
             <a:r>
+              <a:rPr lang="en-US" b="1"/>
+              <a:t>TIMING: budget 1:00 for this slide (cum 76:00-77:00 of 90:00).</a:t>
+            </a:r>
+          </a:p>
+          <a:p>
+            <a:endParaRPr lang="en-US" b="1"/>
+          </a:p>
+          <a:p>
+            <a:r>
               <a:rPr dirty="0"/>
               <a:t>DOCUMENTARY VOICE — spoken live, slower than anything else in the deck.</a:t>
             </a:r>
@@ -5191,6 +5665,15 @@
           <a:lstStyle/>
           <a:p>
             <a:r>
+              <a:rPr lang="en-US" b="1"/>
+              <a:t>TIMING: budget 1:00 for this slide (cum 77:00-78:00 of 90:00), then open Q&amp;A gets ~12:00 to 90:00.</a:t>
+            </a:r>
+          </a:p>
+          <a:p>
+            <a:endParaRPr lang="en-US" b="1"/>
+          </a:p>
+          <a:p>
+            <a:r>
               <a:t>STRAIGHT delivery, warm. This is the handoff into the open Q&amp;A, roughly 14 minutes — there has been no interim pocket since section 5, so the room has been banking questions. Invite them explicitly rather than just stopping talking.</a:t>
             </a:r>
           </a:p>
@@ -5293,6 +5776,15 @@
           <a:lstStyle/>
           <a:p>
             <a:r>
+              <a:rPr lang="en-US" b="1"/>
+              <a:t>TIMING: budget 1:15 for this slide (cum 4:30-5:45 of 90:00).</a:t>
+            </a:r>
+          </a:p>
+          <a:p>
+            <a:endParaRPr lang="en-US" b="1"/>
+          </a:p>
+          <a:p>
+            <a:r>
               <a:t>Straight delivery, and keep it brisk — this is a framing slide, not a deep dive.</a:t>
             </a:r>
           </a:p>
@@ -5403,6 +5895,15 @@
           <a:lstStyle/>
           <a:p>
             <a:r>
+              <a:rPr lang="en-US" b="1"/>
+              <a:t>TIMING: budget 2:15 for this slide (cum 5:45-8:00 of 90:00).</a:t>
+            </a:r>
+          </a:p>
+          <a:p>
+            <a:endParaRPr lang="en-US" b="1"/>
+          </a:p>
+          <a:p>
+            <a:r>
               <a:t>Straight delivery, move quickly — five rows, roughly fifteen seconds each, do not read them verbatim. Frame it up front as “even if you delete the entire AI argument, here is why teams still move.”</a:t>
             </a:r>
           </a:p>
@@ -5505,6 +6006,15 @@
           <a:lstStyle/>
           <a:p>
             <a:r>
+              <a:rPr lang="en-US" b="1"/>
+              <a:t>TIMING: budget 0:20 for this slide (cum 8:00-8:20 of 90:00).</a:t>
+            </a:r>
+          </a:p>
+          <a:p>
+            <a:endParaRPr lang="en-US" b="1"/>
+          </a:p>
+          <a:p>
+            <a:r>
               <a:rPr lang="en-US" dirty="0"/>
               <a:t>DOCUMENTARY VOICE — the only register for this slide. Deliver slowly, deadpan, faintly awed, same conceit as section 1's opener. Pause after the line, then go straight back to normal delivery for the scorecard slide.</a:t>
             </a:r>
@@ -5590,6 +6100,15 @@
         <p:txBody>
           <a:bodyPr/>
           <a:lstStyle/>
+          <a:p>
+            <a:r>
+              <a:rPr lang="en-US" b="1"/>
+              <a:t>TIMING: budget 2:05 for this slide (cum 8:20-10:25 of 90:00).</a:t>
+            </a:r>
+          </a:p>
+          <a:p>
+            <a:endParaRPr lang="en-US" b="1"/>
+          </a:p>
           <a:p>
             <a:r>
               <a:rPr dirty="0"/>
@@ -32004,7 +32523,7 @@
         </p:nvSpPr>
         <p:spPr>
           <a:xfrm>
-            <a:off x="777240" y="2776886"/>
+            <a:off x="777240" y="2766436"/>
             <a:ext cx="6035040" cy="731520"/>
           </a:xfrm>
           <a:prstGeom prst="rect">
@@ -32115,7 +32634,7 @@
         </p:nvSpPr>
         <p:spPr>
           <a:xfrm>
-            <a:off x="777240" y="4786465"/>
+            <a:off x="777240" y="4723765"/>
             <a:ext cx="6035040" cy="411480"/>
           </a:xfrm>
           <a:prstGeom prst="rect">
@@ -32279,7 +32798,7 @@
         <p:spPr>
           <a:xfrm>
             <a:off x="7626076" y="5165054"/>
-            <a:ext cx="3931920" cy="700192"/>
+            <a:ext cx="3931920" cy="915635"/>
           </a:xfrm>
           <a:prstGeom prst="rect">
             <a:avLst/>
@@ -32352,6 +32871,34 @@
               </a:rPr>
               <a:t>Every note behind this talk</a:t>
             </a:r>
+            <a:endParaRPr lang="en-US" sz="1150" b="0" dirty="0">
+              <a:solidFill>
+                <a:srgbClr val="2B2B2B"/>
+              </a:solidFill>
+              <a:latin typeface="Calibri"/>
+            </a:endParaRPr>
+          </a:p>
+          <a:p>
+            <a:pPr algn="ctr">
+              <a:spcBef>
+                <a:spcPts val="300"/>
+              </a:spcBef>
+            </a:pPr>
+            <a:r>
+              <a:rPr lang="en-US" sz="1150" dirty="0">
+                <a:solidFill>
+                  <a:srgbClr val="2B2B2B"/>
+                </a:solidFill>
+                <a:latin typeface="Calibri"/>
+              </a:rPr>
+              <a:t>Link to session feedback</a:t>
+            </a:r>
+            <a:endParaRPr sz="1150" b="0" dirty="0">
+              <a:solidFill>
+                <a:srgbClr val="2B2B2B"/>
+              </a:solidFill>
+              <a:latin typeface="Calibri"/>
+            </a:endParaRPr>
           </a:p>
         </p:txBody>
       </p:sp>

</xml_diff>